<commit_message>
S12: add 情報設計_記入例 sheet + purge paper-based work references
- Add "情報設計_記入例" sheet: fully filled reference sheet (保険営業
  プランナー想定) so students see a completed design before filling
  their own. Green C-column = 記入見本, extra D-column = 判断理由.
- S12 ex1 target/situation now points students at the 記入例 sheet
  first for orientation, then back to 情報設計 to fill in their own.
- Remove "紙 or スプシで" / "紙で設計" / "紙に書く" phrasing from S11
  walkthrough, S12 slides, and S12 README.
- Add lecture_pptx/CLAUDE.md: codify no-paper-work rule + spreadsheet
  template pattern (テンプレ + 記入例 + 相談ログ の3点セット) for all
  future workshop design.

Co-Authored-By: Claude Opus 4.7 (1M context) <noreply@anthropic.com>
Claude-Session: https://claude.ai/code/session_01MLnStsm4YQNeGye3rc2BGH
</commit_message>
<xml_diff>
--- a/lecture_pptx/out/s12/ワーク01.pptx
+++ b/lecture_pptx/out/s12/ワーク01.pptx
@@ -1845,7 +1845,7 @@
                 <a:ea typeface="Yu Gothic UI" pitchFamily="34" charset="-122"/>
                 <a:cs typeface="Yu Gothic UI" pitchFamily="34" charset="-120"/>
               </a:rPr>
-              <a:t>誰に・何を・どこから、を紙とスプシで固めてから実装に入る。</a:t>
+              <a:t>誰に・何を・どこから、を設計スプシで固めてから実装に入る。</a:t>
             </a:r>
             <a:endParaRPr lang="en-US" sz="1300" dirty="0"/>
           </a:p>
@@ -3296,7 +3296,7 @@
                 <a:ea typeface="Yu Gothic UI" pitchFamily="34" charset="-122"/>
                 <a:cs typeface="Yu Gothic UI" pitchFamily="34" charset="-120"/>
               </a:rPr>
-              <a:t>あらかじめ用意された「情報設計テンプレ」スプシに、講師の解説と Gemini との相談で、</a:t>
+              <a:t>スプシ「情報設計」に、講師解説+Geminiと相談しながら、あなた自身の運用に合った項目を書き込む。</a:t>
             </a:r>
             <a:endParaRPr lang="en-US" sz="1400" dirty="0"/>
           </a:p>
@@ -3316,7 +3316,7 @@
                 <a:ea typeface="Yu Gothic UI" pitchFamily="34" charset="-122"/>
                 <a:cs typeface="Yu Gothic UI" pitchFamily="34" charset="-120"/>
               </a:rPr>
-              <a:t>あなた自身の運用に合った項目を書き込んでいく。判断基準を固めるのが目的。</a:t>
+              <a:t>完成イメージがわからない時は 別シート「情報設計_記入例」に フル記入見本 を用意。</a:t>
             </a:r>
             <a:endParaRPr lang="en-US" sz="1400" dirty="0"/>
           </a:p>
@@ -3445,7 +3445,7 @@
                 <a:ea typeface="Yu Gothic UI" pitchFamily="34" charset="-122"/>
                 <a:cs typeface="Yu Gothic UI" pitchFamily="34" charset="-120"/>
               </a:rPr>
-              <a:t>まず「考え方」列を先に読む(丸暗記ではなく理解する)</a:t>
+              <a:t>記入例シートは"骨格の参考"、そのまま写さず自分に置き換える</a:t>
             </a:r>
             <a:endParaRPr lang="en-US" sz="1400" dirty="0"/>
           </a:p>
@@ -3466,7 +3466,7 @@
                 <a:ea typeface="Yu Gothic UI" pitchFamily="34" charset="-122"/>
                 <a:cs typeface="Yu Gothic UI" pitchFamily="34" charset="-120"/>
               </a:rPr>
-              <a:t>テンプレ例をそのまま写さない、自分の運用に合わせて調整する</a:t>
+              <a:t>B列「考え方」を読まずにC列を書くのはNG(理由なきコピペになる)</a:t>
             </a:r>
             <a:endParaRPr lang="en-US" sz="1400" dirty="0"/>
           </a:p>
@@ -3637,7 +3637,7 @@
                 <a:ea typeface="Yu Gothic UI" pitchFamily="34" charset="-122"/>
                 <a:cs typeface="Yu Gothic UI" pitchFamily="34" charset="-120"/>
               </a:rPr>
-              <a:t>スプシ「情報設計」テンプレを開く(項目/考え方/あなたの答え/例 の4列)</a:t>
+              <a:t>「情報設計_記入例」シート(完成見本)を先に眺めて、埋まった全体像を掴む</a:t>
             </a:r>
             <a:endParaRPr lang="en-US" sz="1400" dirty="0"/>
           </a:p>
@@ -3658,7 +3658,7 @@
                 <a:ea typeface="Yu Gothic UI" pitchFamily="34" charset="-122"/>
                 <a:cs typeface="Yu Gothic UI" pitchFamily="34" charset="-120"/>
               </a:rPr>
-              <a:t>「考え方・判断基準」列を先に読み、なぜこの項目を決める必要があるかを理解</a:t>
+              <a:t>「情報設計」シートに戻り、B列「考え方・判断基準」を1項目ずつ読む</a:t>
             </a:r>
             <a:endParaRPr lang="en-US" sz="1400" dirty="0"/>
           </a:p>
@@ -3679,7 +3679,7 @@
                 <a:ea typeface="Yu Gothic UI" pitchFamily="34" charset="-122"/>
                 <a:cs typeface="Yu Gothic UI" pitchFamily="34" charset="-120"/>
               </a:rPr>
-              <a:t>各項目の「あなたの答え」列を、自分の運用に合わせて埋める</a:t>
+              <a:t>各項目の C列「あなたの答え」を、自分の運用に合わせて記入</a:t>
             </a:r>
             <a:endParaRPr lang="en-US" sz="1400" dirty="0"/>
           </a:p>
@@ -3700,7 +3700,7 @@
                 <a:ea typeface="Yu Gothic UI" pitchFamily="34" charset="-122"/>
                 <a:cs typeface="Yu Gothic UI" pitchFamily="34" charset="-120"/>
               </a:rPr>
-              <a:t>迷ったところは Gemini に「私の場合はどう?」と相談しながら進める</a:t>
+              <a:t>迷ったら Gemini に相談、質問と結論は「Gemini相談ログ」シートに残す</a:t>
             </a:r>
             <a:endParaRPr lang="en-US" sz="1400" dirty="0"/>
           </a:p>
@@ -3721,7 +3721,7 @@
                 <a:ea typeface="Yu Gothic UI" pitchFamily="34" charset="-122"/>
                 <a:cs typeface="Yu Gothic UI" pitchFamily="34" charset="-120"/>
               </a:rPr>
-              <a:t>完成したスプシが 演習2 (GAS実装) の "仕様書" になる</a:t>
+              <a:t>完成したC列が 演習2 (GAS実装) の "仕様書" になる</a:t>
             </a:r>
             <a:endParaRPr lang="en-US" sz="1400" dirty="0"/>
           </a:p>
@@ -6225,7 +6225,7 @@
                 <a:ea typeface="Yu Gothic UI" pitchFamily="34" charset="-122"/>
                 <a:cs typeface="Yu Gothic UI" pitchFamily="34" charset="-120"/>
               </a:rPr>
-              <a:t>判断基準を紙(設計シート)で決めてから実装に入ると、AI出力の良し悪しを判定できる。</a:t>
+              <a:t>判断基準を設計スプシで決めてから実装に入ると、AI出力の良し悪しを判定できる。</a:t>
             </a:r>
             <a:endParaRPr lang="en-US" sz="1300" dirty="0"/>
           </a:p>

</xml_diff>